<commit_message>
Enhance OPC demo documentation and deliverables with updated 26-rule checklist, new agent prompts, and comprehensive run report. Include full pipeline demo video, refined README, and additional PPT assets for clearer presentation of contract audit workflow. Co-authored-by: Cursor <cursoragent@cursor.com>
</commit_message>
<xml_diff>
--- a/outputs/opc-demo/ppt/opc-xiaohuanxiong-workflow-submission.pptx
+++ b/outputs/opc-demo/ppt/opc-xiaohuanxiong-workflow-submission.pptx
@@ -2,22 +2,22 @@
 <file path=ppt/presentation.xml><?xml version="1.0" encoding="utf-8"?>
 <p:presentation xmlns:p="http://schemas.openxmlformats.org/presentationml/2006/main">
   <p:sldMasterIdLst>
-    <p:sldMasterId xmlns:r="http://schemas.openxmlformats.org/officeDocument/2006/relationships" id="2147483648" r:id="R7517f6b74c2a41dc"/>
+    <p:sldMasterId xmlns:r="http://schemas.openxmlformats.org/officeDocument/2006/relationships" id="2147483648" r:id="R46ec7947b02a438b"/>
   </p:sldMasterIdLst>
   <p:notesMasterIdLst>
-    <p:notesMasterId xmlns:r="http://schemas.openxmlformats.org/officeDocument/2006/relationships" r:id="R68970562af7d48a6"/>
+    <p:notesMasterId xmlns:r="http://schemas.openxmlformats.org/officeDocument/2006/relationships" r:id="R58fedee9710d445f"/>
   </p:notesMasterIdLst>
   <p:sldIdLst>
-    <p:sldId xmlns:r="http://schemas.openxmlformats.org/officeDocument/2006/relationships" id="256" r:id="R01bc18f3805f4186"/>
-    <p:sldId xmlns:r="http://schemas.openxmlformats.org/officeDocument/2006/relationships" id="257" r:id="R4456921b6a874080"/>
-    <p:sldId xmlns:r="http://schemas.openxmlformats.org/officeDocument/2006/relationships" id="258" r:id="R04158f3b3c244ed2"/>
-    <p:sldId xmlns:r="http://schemas.openxmlformats.org/officeDocument/2006/relationships" id="259" r:id="R5fac4ec301424932"/>
-    <p:sldId xmlns:r="http://schemas.openxmlformats.org/officeDocument/2006/relationships" id="260" r:id="Ra84f8e107a9846c4"/>
-    <p:sldId xmlns:r="http://schemas.openxmlformats.org/officeDocument/2006/relationships" id="261" r:id="R0d9d6fba7ba441ca"/>
-    <p:sldId xmlns:r="http://schemas.openxmlformats.org/officeDocument/2006/relationships" id="262" r:id="Rbf39e090d70e4f96"/>
-    <p:sldId xmlns:r="http://schemas.openxmlformats.org/officeDocument/2006/relationships" id="263" r:id="R03952e1f7fce44bc"/>
-    <p:sldId xmlns:r="http://schemas.openxmlformats.org/officeDocument/2006/relationships" id="264" r:id="Rf2be4617e7eb48bc"/>
-    <p:sldId xmlns:r="http://schemas.openxmlformats.org/officeDocument/2006/relationships" id="265" r:id="Rcf6597ae98e44dd1"/>
+    <p:sldId xmlns:r="http://schemas.openxmlformats.org/officeDocument/2006/relationships" id="256" r:id="Ra516dfaddeeb4f96"/>
+    <p:sldId xmlns:r="http://schemas.openxmlformats.org/officeDocument/2006/relationships" id="257" r:id="R7dcb311df4a54da7"/>
+    <p:sldId xmlns:r="http://schemas.openxmlformats.org/officeDocument/2006/relationships" id="258" r:id="R0955f4b8afcc44ce"/>
+    <p:sldId xmlns:r="http://schemas.openxmlformats.org/officeDocument/2006/relationships" id="259" r:id="R11e83288ab5540be"/>
+    <p:sldId xmlns:r="http://schemas.openxmlformats.org/officeDocument/2006/relationships" id="260" r:id="R4a4e3030ad694431"/>
+    <p:sldId xmlns:r="http://schemas.openxmlformats.org/officeDocument/2006/relationships" id="261" r:id="R762ed4f541014aad"/>
+    <p:sldId xmlns:r="http://schemas.openxmlformats.org/officeDocument/2006/relationships" id="262" r:id="Re59e3bc0d81f4cea"/>
+    <p:sldId xmlns:r="http://schemas.openxmlformats.org/officeDocument/2006/relationships" id="263" r:id="R3dc4fe2281af46b4"/>
+    <p:sldId xmlns:r="http://schemas.openxmlformats.org/officeDocument/2006/relationships" id="264" r:id="R0ff8cbd6db7c4d64"/>
+    <p:sldId xmlns:r="http://schemas.openxmlformats.org/officeDocument/2006/relationships" id="265" r:id="R1578000812414075"/>
   </p:sldIdLst>
   <p:sldSz cx="12192000" cy="6858000"/>
   <p:notesSz cx="6858000" cy="9144000"/>
@@ -1204,7 +1204,7 @@
   </p:cSld>
   <p:clrMap bg1="lt1" tx1="dk1" bg2="lt2" tx2="dk2" accent1="accent1" accent2="accent2" accent3="accent3" accent4="accent4" accent5="accent5" accent6="accent6" hlink="hlink" folHlink="folHlink"/>
   <p:sldLayoutIdLst>
-    <p:sldLayoutId xmlns:r="http://schemas.openxmlformats.org/officeDocument/2006/relationships" id="2147483649" r:id="Rc3462e2a731e411c"/>
+    <p:sldLayoutId xmlns:r="http://schemas.openxmlformats.org/officeDocument/2006/relationships" id="2147483649" r:id="Ra7180a2ed60f4a1a"/>
   </p:sldLayoutIdLst>
   <p:txStyles>
     <p:titleStyle>
@@ -1759,7 +1759,7 @@
           <p:nvPr/>
         </p:nvPicPr>
         <p:blipFill>
-          <a:blip xmlns:r="http://schemas.openxmlformats.org/officeDocument/2006/relationships" xmlns:a="http://schemas.openxmlformats.org/drawingml/2006/main" r:embed="R05dfb82934f54492"/>
+          <a:blip xmlns:r="http://schemas.openxmlformats.org/officeDocument/2006/relationships" xmlns:a="http://schemas.openxmlformats.org/drawingml/2006/main" r:embed="Rb8cd3f032aa146ac"/>
           <a:srcRect xmlns:a="http://schemas.openxmlformats.org/drawingml/2006/main" l="0" t="0" r="0" b="0"/>
           <a:stretch xmlns:a="http://schemas.openxmlformats.org/drawingml/2006/main">
             <a:fillRect l="0" t="0" r="0" b="0"/>
@@ -1778,7 +1778,7 @@
     </p:spTree>
     <p:extLst>
       <p:ext uri="{BB962C8B-B14F-4D97-AF65-F5344CB8AC3E}">
-        <p14:creationId xmlns:p14="http://schemas.microsoft.com/office/powerpoint/2010/main" val="869698617"/>
+        <p14:creationId xmlns:p14="http://schemas.microsoft.com/office/powerpoint/2010/main" val="1116079810"/>
       </p:ext>
     </p:extLst>
   </p:cSld>
@@ -1813,7 +1813,7 @@
           <p:nvPr/>
         </p:nvPicPr>
         <p:blipFill>
-          <a:blip xmlns:r="http://schemas.openxmlformats.org/officeDocument/2006/relationships" xmlns:a="http://schemas.openxmlformats.org/drawingml/2006/main" r:embed="R31d7e90ffb07437e"/>
+          <a:blip xmlns:r="http://schemas.openxmlformats.org/officeDocument/2006/relationships" xmlns:a="http://schemas.openxmlformats.org/drawingml/2006/main" r:embed="R6f91b4663fa64e19"/>
           <a:srcRect xmlns:a="http://schemas.openxmlformats.org/drawingml/2006/main" l="0" t="0" r="0" b="0"/>
           <a:stretch xmlns:a="http://schemas.openxmlformats.org/drawingml/2006/main">
             <a:fillRect l="0" t="0" r="0" b="0"/>
@@ -1832,7 +1832,7 @@
     </p:spTree>
     <p:extLst>
       <p:ext uri="{BB962C8B-B14F-4D97-AF65-F5344CB8AC3E}">
-        <p14:creationId xmlns:p14="http://schemas.microsoft.com/office/powerpoint/2010/main" val="651940753"/>
+        <p14:creationId xmlns:p14="http://schemas.microsoft.com/office/powerpoint/2010/main" val="562453825"/>
       </p:ext>
     </p:extLst>
   </p:cSld>
@@ -1867,7 +1867,7 @@
           <p:nvPr/>
         </p:nvPicPr>
         <p:blipFill>
-          <a:blip xmlns:r="http://schemas.openxmlformats.org/officeDocument/2006/relationships" xmlns:a="http://schemas.openxmlformats.org/drawingml/2006/main" r:embed="Rcff769cc9b4b46ea"/>
+          <a:blip xmlns:r="http://schemas.openxmlformats.org/officeDocument/2006/relationships" xmlns:a="http://schemas.openxmlformats.org/drawingml/2006/main" r:embed="Ra64ccf722cc346f5"/>
           <a:srcRect xmlns:a="http://schemas.openxmlformats.org/drawingml/2006/main" l="0" t="0" r="0" b="0"/>
           <a:stretch xmlns:a="http://schemas.openxmlformats.org/drawingml/2006/main">
             <a:fillRect l="0" t="0" r="0" b="0"/>
@@ -1886,7 +1886,7 @@
     </p:spTree>
     <p:extLst>
       <p:ext uri="{BB962C8B-B14F-4D97-AF65-F5344CB8AC3E}">
-        <p14:creationId xmlns:p14="http://schemas.microsoft.com/office/powerpoint/2010/main" val="1169357827"/>
+        <p14:creationId xmlns:p14="http://schemas.microsoft.com/office/powerpoint/2010/main" val="1426453493"/>
       </p:ext>
     </p:extLst>
   </p:cSld>
@@ -1921,7 +1921,7 @@
           <p:nvPr/>
         </p:nvPicPr>
         <p:blipFill>
-          <a:blip xmlns:r="http://schemas.openxmlformats.org/officeDocument/2006/relationships" xmlns:a="http://schemas.openxmlformats.org/drawingml/2006/main" r:embed="R88ed01f2d58d4533"/>
+          <a:blip xmlns:r="http://schemas.openxmlformats.org/officeDocument/2006/relationships" xmlns:a="http://schemas.openxmlformats.org/drawingml/2006/main" r:embed="R4bb3b01be0dc48cb"/>
           <a:srcRect xmlns:a="http://schemas.openxmlformats.org/drawingml/2006/main" l="0" t="0" r="0" b="0"/>
           <a:stretch xmlns:a="http://schemas.openxmlformats.org/drawingml/2006/main">
             <a:fillRect l="0" t="0" r="0" b="0"/>
@@ -1940,7 +1940,7 @@
     </p:spTree>
     <p:extLst>
       <p:ext uri="{BB962C8B-B14F-4D97-AF65-F5344CB8AC3E}">
-        <p14:creationId xmlns:p14="http://schemas.microsoft.com/office/powerpoint/2010/main" val="329082315"/>
+        <p14:creationId xmlns:p14="http://schemas.microsoft.com/office/powerpoint/2010/main" val="957809244"/>
       </p:ext>
     </p:extLst>
   </p:cSld>
@@ -1975,7 +1975,7 @@
           <p:nvPr/>
         </p:nvPicPr>
         <p:blipFill>
-          <a:blip xmlns:r="http://schemas.openxmlformats.org/officeDocument/2006/relationships" xmlns:a="http://schemas.openxmlformats.org/drawingml/2006/main" r:embed="R94b41d19869c45bc"/>
+          <a:blip xmlns:r="http://schemas.openxmlformats.org/officeDocument/2006/relationships" xmlns:a="http://schemas.openxmlformats.org/drawingml/2006/main" r:embed="R78b2690fd77d4c62"/>
           <a:srcRect xmlns:a="http://schemas.openxmlformats.org/drawingml/2006/main" l="0" t="0" r="0" b="0"/>
           <a:stretch xmlns:a="http://schemas.openxmlformats.org/drawingml/2006/main">
             <a:fillRect l="0" t="0" r="0" b="0"/>
@@ -1994,7 +1994,7 @@
     </p:spTree>
     <p:extLst>
       <p:ext uri="{BB962C8B-B14F-4D97-AF65-F5344CB8AC3E}">
-        <p14:creationId xmlns:p14="http://schemas.microsoft.com/office/powerpoint/2010/main" val="1568959766"/>
+        <p14:creationId xmlns:p14="http://schemas.microsoft.com/office/powerpoint/2010/main" val="1173091667"/>
       </p:ext>
     </p:extLst>
   </p:cSld>
@@ -2029,7 +2029,7 @@
           <p:nvPr/>
         </p:nvPicPr>
         <p:blipFill>
-          <a:blip xmlns:r="http://schemas.openxmlformats.org/officeDocument/2006/relationships" xmlns:a="http://schemas.openxmlformats.org/drawingml/2006/main" r:embed="R428f291f2b874051"/>
+          <a:blip xmlns:r="http://schemas.openxmlformats.org/officeDocument/2006/relationships" xmlns:a="http://schemas.openxmlformats.org/drawingml/2006/main" r:embed="Rc757d1a4c37d4e7f"/>
           <a:srcRect xmlns:a="http://schemas.openxmlformats.org/drawingml/2006/main" l="0" t="0" r="0" b="0"/>
           <a:stretch xmlns:a="http://schemas.openxmlformats.org/drawingml/2006/main">
             <a:fillRect l="0" t="0" r="0" b="0"/>
@@ -2048,7 +2048,7 @@
     </p:spTree>
     <p:extLst>
       <p:ext uri="{BB962C8B-B14F-4D97-AF65-F5344CB8AC3E}">
-        <p14:creationId xmlns:p14="http://schemas.microsoft.com/office/powerpoint/2010/main" val="405021356"/>
+        <p14:creationId xmlns:p14="http://schemas.microsoft.com/office/powerpoint/2010/main" val="655865"/>
       </p:ext>
     </p:extLst>
   </p:cSld>
@@ -2083,7 +2083,7 @@
           <p:nvPr/>
         </p:nvPicPr>
         <p:blipFill>
-          <a:blip xmlns:r="http://schemas.openxmlformats.org/officeDocument/2006/relationships" xmlns:a="http://schemas.openxmlformats.org/drawingml/2006/main" r:embed="R7ba6137a3c1d4cc3"/>
+          <a:blip xmlns:r="http://schemas.openxmlformats.org/officeDocument/2006/relationships" xmlns:a="http://schemas.openxmlformats.org/drawingml/2006/main" r:embed="Rc4afa14b43ec4a7b"/>
           <a:srcRect xmlns:a="http://schemas.openxmlformats.org/drawingml/2006/main" l="0" t="0" r="0" b="0"/>
           <a:stretch xmlns:a="http://schemas.openxmlformats.org/drawingml/2006/main">
             <a:fillRect l="0" t="0" r="0" b="0"/>
@@ -2102,7 +2102,7 @@
     </p:spTree>
     <p:extLst>
       <p:ext uri="{BB962C8B-B14F-4D97-AF65-F5344CB8AC3E}">
-        <p14:creationId xmlns:p14="http://schemas.microsoft.com/office/powerpoint/2010/main" val="735092956"/>
+        <p14:creationId xmlns:p14="http://schemas.microsoft.com/office/powerpoint/2010/main" val="469490363"/>
       </p:ext>
     </p:extLst>
   </p:cSld>
@@ -2137,7 +2137,7 @@
           <p:nvPr/>
         </p:nvPicPr>
         <p:blipFill>
-          <a:blip xmlns:r="http://schemas.openxmlformats.org/officeDocument/2006/relationships" xmlns:a="http://schemas.openxmlformats.org/drawingml/2006/main" r:embed="Rbc2067e35c5f4398"/>
+          <a:blip xmlns:r="http://schemas.openxmlformats.org/officeDocument/2006/relationships" xmlns:a="http://schemas.openxmlformats.org/drawingml/2006/main" r:embed="Raa8065b12fc0424c"/>
           <a:srcRect xmlns:a="http://schemas.openxmlformats.org/drawingml/2006/main" l="0" t="0" r="0" b="0"/>
           <a:stretch xmlns:a="http://schemas.openxmlformats.org/drawingml/2006/main">
             <a:fillRect l="0" t="0" r="0" b="0"/>
@@ -2156,7 +2156,7 @@
     </p:spTree>
     <p:extLst>
       <p:ext uri="{BB962C8B-B14F-4D97-AF65-F5344CB8AC3E}">
-        <p14:creationId xmlns:p14="http://schemas.microsoft.com/office/powerpoint/2010/main" val="386649929"/>
+        <p14:creationId xmlns:p14="http://schemas.microsoft.com/office/powerpoint/2010/main" val="723904353"/>
       </p:ext>
     </p:extLst>
   </p:cSld>
@@ -2191,7 +2191,7 @@
           <p:nvPr/>
         </p:nvPicPr>
         <p:blipFill>
-          <a:blip xmlns:r="http://schemas.openxmlformats.org/officeDocument/2006/relationships" xmlns:a="http://schemas.openxmlformats.org/drawingml/2006/main" r:embed="R4ff647e4ba5e48c6"/>
+          <a:blip xmlns:r="http://schemas.openxmlformats.org/officeDocument/2006/relationships" xmlns:a="http://schemas.openxmlformats.org/drawingml/2006/main" r:embed="R6470c9ccdb0c4a55"/>
           <a:srcRect xmlns:a="http://schemas.openxmlformats.org/drawingml/2006/main" l="0" t="0" r="0" b="0"/>
           <a:stretch xmlns:a="http://schemas.openxmlformats.org/drawingml/2006/main">
             <a:fillRect l="0" t="0" r="0" b="0"/>
@@ -2210,7 +2210,7 @@
     </p:spTree>
     <p:extLst>
       <p:ext uri="{BB962C8B-B14F-4D97-AF65-F5344CB8AC3E}">
-        <p14:creationId xmlns:p14="http://schemas.microsoft.com/office/powerpoint/2010/main" val="642141748"/>
+        <p14:creationId xmlns:p14="http://schemas.microsoft.com/office/powerpoint/2010/main" val="206547577"/>
       </p:ext>
     </p:extLst>
   </p:cSld>
@@ -2245,7 +2245,7 @@
           <p:nvPr/>
         </p:nvPicPr>
         <p:blipFill>
-          <a:blip xmlns:r="http://schemas.openxmlformats.org/officeDocument/2006/relationships" xmlns:a="http://schemas.openxmlformats.org/drawingml/2006/main" r:embed="Rb7f557b107a448df"/>
+          <a:blip xmlns:r="http://schemas.openxmlformats.org/officeDocument/2006/relationships" xmlns:a="http://schemas.openxmlformats.org/drawingml/2006/main" r:embed="Ra901ceb8f88c4e8a"/>
           <a:srcRect xmlns:a="http://schemas.openxmlformats.org/drawingml/2006/main" l="0" t="0" r="0" b="0"/>
           <a:stretch xmlns:a="http://schemas.openxmlformats.org/drawingml/2006/main">
             <a:fillRect l="0" t="0" r="0" b="0"/>
@@ -2264,7 +2264,7 @@
     </p:spTree>
     <p:extLst>
       <p:ext uri="{BB962C8B-B14F-4D97-AF65-F5344CB8AC3E}">
-        <p14:creationId xmlns:p14="http://schemas.microsoft.com/office/powerpoint/2010/main" val="1210494962"/>
+        <p14:creationId xmlns:p14="http://schemas.microsoft.com/office/powerpoint/2010/main" val="215744087"/>
       </p:ext>
     </p:extLst>
   </p:cSld>

</xml_diff>

<commit_message>
Refactor and enhance documentation for the contract audit workflow, including updates to the README, new competition submission materials, and the addition of a detailed guide for the Feishu closed-loop integration. Remove outdated demo assets and improve clarity in the project structure. Co-authored-by: Cursor <cursoragent@cursor.com>
</commit_message>
<xml_diff>
--- a/outputs/opc-demo/ppt/opc-xiaohuanxiong-workflow-submission.pptx
+++ b/outputs/opc-demo/ppt/opc-xiaohuanxiong-workflow-submission.pptx
@@ -2,22 +2,24 @@
 <file path=ppt/presentation.xml><?xml version="1.0" encoding="utf-8"?>
 <p:presentation xmlns:p="http://schemas.openxmlformats.org/presentationml/2006/main">
   <p:sldMasterIdLst>
-    <p:sldMasterId xmlns:r="http://schemas.openxmlformats.org/officeDocument/2006/relationships" id="2147483648" r:id="R46ec7947b02a438b"/>
+    <p:sldMasterId xmlns:r="http://schemas.openxmlformats.org/officeDocument/2006/relationships" id="2147483648" r:id="Re238ada9f7624c2c"/>
   </p:sldMasterIdLst>
   <p:notesMasterIdLst>
-    <p:notesMasterId xmlns:r="http://schemas.openxmlformats.org/officeDocument/2006/relationships" r:id="R58fedee9710d445f"/>
+    <p:notesMasterId xmlns:r="http://schemas.openxmlformats.org/officeDocument/2006/relationships" r:id="Rdaa40abaed3d4ee6"/>
   </p:notesMasterIdLst>
   <p:sldIdLst>
-    <p:sldId xmlns:r="http://schemas.openxmlformats.org/officeDocument/2006/relationships" id="256" r:id="Ra516dfaddeeb4f96"/>
-    <p:sldId xmlns:r="http://schemas.openxmlformats.org/officeDocument/2006/relationships" id="257" r:id="R7dcb311df4a54da7"/>
-    <p:sldId xmlns:r="http://schemas.openxmlformats.org/officeDocument/2006/relationships" id="258" r:id="R0955f4b8afcc44ce"/>
-    <p:sldId xmlns:r="http://schemas.openxmlformats.org/officeDocument/2006/relationships" id="259" r:id="R11e83288ab5540be"/>
-    <p:sldId xmlns:r="http://schemas.openxmlformats.org/officeDocument/2006/relationships" id="260" r:id="R4a4e3030ad694431"/>
-    <p:sldId xmlns:r="http://schemas.openxmlformats.org/officeDocument/2006/relationships" id="261" r:id="R762ed4f541014aad"/>
-    <p:sldId xmlns:r="http://schemas.openxmlformats.org/officeDocument/2006/relationships" id="262" r:id="Re59e3bc0d81f4cea"/>
-    <p:sldId xmlns:r="http://schemas.openxmlformats.org/officeDocument/2006/relationships" id="263" r:id="R3dc4fe2281af46b4"/>
-    <p:sldId xmlns:r="http://schemas.openxmlformats.org/officeDocument/2006/relationships" id="264" r:id="R0ff8cbd6db7c4d64"/>
-    <p:sldId xmlns:r="http://schemas.openxmlformats.org/officeDocument/2006/relationships" id="265" r:id="R1578000812414075"/>
+    <p:sldId xmlns:r="http://schemas.openxmlformats.org/officeDocument/2006/relationships" id="256" r:id="Rb3823f609271469d"/>
+    <p:sldId xmlns:r="http://schemas.openxmlformats.org/officeDocument/2006/relationships" id="257" r:id="Rdc21c21223ea45b3"/>
+    <p:sldId xmlns:r="http://schemas.openxmlformats.org/officeDocument/2006/relationships" id="258" r:id="R3b9a2887114c484d"/>
+    <p:sldId xmlns:r="http://schemas.openxmlformats.org/officeDocument/2006/relationships" id="259" r:id="Rcbd8e7cfb8f1454d"/>
+    <p:sldId xmlns:r="http://schemas.openxmlformats.org/officeDocument/2006/relationships" id="260" r:id="R9b1d6051afe74136"/>
+    <p:sldId xmlns:r="http://schemas.openxmlformats.org/officeDocument/2006/relationships" id="261" r:id="R5303e0cab133443f"/>
+    <p:sldId xmlns:r="http://schemas.openxmlformats.org/officeDocument/2006/relationships" id="262" r:id="R3e896448f0c14468"/>
+    <p:sldId xmlns:r="http://schemas.openxmlformats.org/officeDocument/2006/relationships" id="263" r:id="R6c9df94211094232"/>
+    <p:sldId xmlns:r="http://schemas.openxmlformats.org/officeDocument/2006/relationships" id="264" r:id="Rf79a39d1a2f24817"/>
+    <p:sldId xmlns:r="http://schemas.openxmlformats.org/officeDocument/2006/relationships" id="265" r:id="R1ab919669d144fe4"/>
+    <p:sldId xmlns:r="http://schemas.openxmlformats.org/officeDocument/2006/relationships" id="266" r:id="R24032efe51e74445"/>
+    <p:sldId xmlns:r="http://schemas.openxmlformats.org/officeDocument/2006/relationships" id="267" r:id="R653cee51507a4dda"/>
   </p:sldIdLst>
   <p:sldSz cx="12192000" cy="6858000"/>
   <p:notesSz cx="6858000" cy="9144000"/>
@@ -638,6 +640,138 @@
 </p:notes>
 </file>
 
+<file path=ppt/notesSlides/notesSlide11.xml><?xml version="1.0" encoding="utf-8"?>
+<p:notes xmlns:p="http://schemas.openxmlformats.org/presentationml/2006/main">
+  <p:cSld>
+    <p:spTree>
+      <p:nvGrpSpPr>
+        <p:cNvPr id="1" name=""/>
+        <p:cNvGrpSpPr/>
+        <p:nvPr/>
+      </p:nvGrpSpPr>
+      <p:grpSpPr>
+        <a:xfrm xmlns:a="http://schemas.openxmlformats.org/drawingml/2006/main"/>
+      </p:grpSpPr>
+      <p:sp>
+        <p:nvSpPr>
+          <p:cNvPr id="2" name="Slide Image Placeholder 1"/>
+          <p:cNvSpPr>
+            <a:spLocks xmlns:a="http://schemas.openxmlformats.org/drawingml/2006/main" noGrp="1"/>
+          </p:cNvSpPr>
+          <p:nvPr>
+            <p:ph type="sldImg" idx="0"/>
+          </p:nvPr>
+        </p:nvSpPr>
+        <p:spPr/>
+      </p:sp>
+      <p:sp>
+        <p:nvSpPr>
+          <p:cNvPr id="3" name="Notes Placeholder 2"/>
+          <p:cNvSpPr>
+            <a:spLocks xmlns:a="http://schemas.openxmlformats.org/drawingml/2006/main" noGrp="1"/>
+          </p:cNvSpPr>
+          <p:nvPr>
+            <p:ph type="body" idx="1"/>
+          </p:nvPr>
+        </p:nvSpPr>
+        <p:spPr/>
+        <p:txBody>
+          <a:bodyPr xmlns:a="http://schemas.openxmlformats.org/drawingml/2006/main"/>
+          <a:lstStyle xmlns:a="http://schemas.openxmlformats.org/drawingml/2006/main"/>
+          <a:p xmlns:a="http://schemas.openxmlformats.org/drawingml/2006/main"/>
+        </p:txBody>
+      </p:sp>
+      <p:sp>
+        <p:nvSpPr>
+          <p:cNvPr id="4" name="Slide Number Placeholder 3"/>
+          <p:cNvSpPr>
+            <a:spLocks xmlns:a="http://schemas.openxmlformats.org/drawingml/2006/main" noGrp="1"/>
+          </p:cNvSpPr>
+          <p:nvPr>
+            <p:ph type="sldNum" idx="5"/>
+          </p:nvPr>
+        </p:nvSpPr>
+        <p:spPr/>
+        <p:txBody>
+          <a:bodyPr xmlns:a="http://schemas.openxmlformats.org/drawingml/2006/main"/>
+          <a:lstStyle xmlns:a="http://schemas.openxmlformats.org/drawingml/2006/main"/>
+          <a:p xmlns:a="http://schemas.openxmlformats.org/drawingml/2006/main"/>
+        </p:txBody>
+      </p:sp>
+    </p:spTree>
+  </p:cSld>
+  <p:clrMapOvr>
+    <a:masterClrMapping xmlns:a="http://schemas.openxmlformats.org/drawingml/2006/main"/>
+  </p:clrMapOvr>
+</p:notes>
+</file>
+
+<file path=ppt/notesSlides/notesSlide12.xml><?xml version="1.0" encoding="utf-8"?>
+<p:notes xmlns:p="http://schemas.openxmlformats.org/presentationml/2006/main">
+  <p:cSld>
+    <p:spTree>
+      <p:nvGrpSpPr>
+        <p:cNvPr id="1" name=""/>
+        <p:cNvGrpSpPr/>
+        <p:nvPr/>
+      </p:nvGrpSpPr>
+      <p:grpSpPr>
+        <a:xfrm xmlns:a="http://schemas.openxmlformats.org/drawingml/2006/main"/>
+      </p:grpSpPr>
+      <p:sp>
+        <p:nvSpPr>
+          <p:cNvPr id="2" name="Slide Image Placeholder 1"/>
+          <p:cNvSpPr>
+            <a:spLocks xmlns:a="http://schemas.openxmlformats.org/drawingml/2006/main" noGrp="1"/>
+          </p:cNvSpPr>
+          <p:nvPr>
+            <p:ph type="sldImg" idx="0"/>
+          </p:nvPr>
+        </p:nvSpPr>
+        <p:spPr/>
+      </p:sp>
+      <p:sp>
+        <p:nvSpPr>
+          <p:cNvPr id="3" name="Notes Placeholder 2"/>
+          <p:cNvSpPr>
+            <a:spLocks xmlns:a="http://schemas.openxmlformats.org/drawingml/2006/main" noGrp="1"/>
+          </p:cNvSpPr>
+          <p:nvPr>
+            <p:ph type="body" idx="1"/>
+          </p:nvPr>
+        </p:nvSpPr>
+        <p:spPr/>
+        <p:txBody>
+          <a:bodyPr xmlns:a="http://schemas.openxmlformats.org/drawingml/2006/main"/>
+          <a:lstStyle xmlns:a="http://schemas.openxmlformats.org/drawingml/2006/main"/>
+          <a:p xmlns:a="http://schemas.openxmlformats.org/drawingml/2006/main"/>
+        </p:txBody>
+      </p:sp>
+      <p:sp>
+        <p:nvSpPr>
+          <p:cNvPr id="4" name="Slide Number Placeholder 3"/>
+          <p:cNvSpPr>
+            <a:spLocks xmlns:a="http://schemas.openxmlformats.org/drawingml/2006/main" noGrp="1"/>
+          </p:cNvSpPr>
+          <p:nvPr>
+            <p:ph type="sldNum" idx="5"/>
+          </p:nvPr>
+        </p:nvSpPr>
+        <p:spPr/>
+        <p:txBody>
+          <a:bodyPr xmlns:a="http://schemas.openxmlformats.org/drawingml/2006/main"/>
+          <a:lstStyle xmlns:a="http://schemas.openxmlformats.org/drawingml/2006/main"/>
+          <a:p xmlns:a="http://schemas.openxmlformats.org/drawingml/2006/main"/>
+        </p:txBody>
+      </p:sp>
+    </p:spTree>
+  </p:cSld>
+  <p:clrMapOvr>
+    <a:masterClrMapping xmlns:a="http://schemas.openxmlformats.org/drawingml/2006/main"/>
+  </p:clrMapOvr>
+</p:notes>
+</file>
+
 <file path=ppt/notesSlides/notesSlide2.xml><?xml version="1.0" encoding="utf-8"?>
 <p:notes xmlns:p="http://schemas.openxmlformats.org/presentationml/2006/main">
   <p:cSld>
@@ -1204,7 +1338,7 @@
   </p:cSld>
   <p:clrMap bg1="lt1" tx1="dk1" bg2="lt2" tx2="dk2" accent1="accent1" accent2="accent2" accent3="accent3" accent4="accent4" accent5="accent5" accent6="accent6" hlink="hlink" folHlink="folHlink"/>
   <p:sldLayoutIdLst>
-    <p:sldLayoutId xmlns:r="http://schemas.openxmlformats.org/officeDocument/2006/relationships" id="2147483649" r:id="Ra7180a2ed60f4a1a"/>
+    <p:sldLayoutId xmlns:r="http://schemas.openxmlformats.org/officeDocument/2006/relationships" id="2147483649" r:id="R81b9627f54c34ad8"/>
   </p:sldLayoutIdLst>
   <p:txStyles>
     <p:titleStyle>
@@ -1759,7 +1893,7 @@
           <p:nvPr/>
         </p:nvPicPr>
         <p:blipFill>
-          <a:blip xmlns:r="http://schemas.openxmlformats.org/officeDocument/2006/relationships" xmlns:a="http://schemas.openxmlformats.org/drawingml/2006/main" r:embed="Rb8cd3f032aa146ac"/>
+          <a:blip xmlns:r="http://schemas.openxmlformats.org/officeDocument/2006/relationships" xmlns:a="http://schemas.openxmlformats.org/drawingml/2006/main" r:embed="Rc2581216b3fc472d"/>
           <a:srcRect xmlns:a="http://schemas.openxmlformats.org/drawingml/2006/main" l="0" t="0" r="0" b="0"/>
           <a:stretch xmlns:a="http://schemas.openxmlformats.org/drawingml/2006/main">
             <a:fillRect l="0" t="0" r="0" b="0"/>
@@ -1778,7 +1912,7 @@
     </p:spTree>
     <p:extLst>
       <p:ext uri="{BB962C8B-B14F-4D97-AF65-F5344CB8AC3E}">
-        <p14:creationId xmlns:p14="http://schemas.microsoft.com/office/powerpoint/2010/main" val="1116079810"/>
+        <p14:creationId xmlns:p14="http://schemas.microsoft.com/office/powerpoint/2010/main" val="1187767200"/>
       </p:ext>
     </p:extLst>
   </p:cSld>
@@ -1813,7 +1947,7 @@
           <p:nvPr/>
         </p:nvPicPr>
         <p:blipFill>
-          <a:blip xmlns:r="http://schemas.openxmlformats.org/officeDocument/2006/relationships" xmlns:a="http://schemas.openxmlformats.org/drawingml/2006/main" r:embed="R6f91b4663fa64e19"/>
+          <a:blip xmlns:r="http://schemas.openxmlformats.org/officeDocument/2006/relationships" xmlns:a="http://schemas.openxmlformats.org/drawingml/2006/main" r:embed="Rb0f62dbdb85842b4"/>
           <a:srcRect xmlns:a="http://schemas.openxmlformats.org/drawingml/2006/main" l="0" t="0" r="0" b="0"/>
           <a:stretch xmlns:a="http://schemas.openxmlformats.org/drawingml/2006/main">
             <a:fillRect l="0" t="0" r="0" b="0"/>
@@ -1832,14 +1966,14 @@
     </p:spTree>
     <p:extLst>
       <p:ext uri="{BB962C8B-B14F-4D97-AF65-F5344CB8AC3E}">
-        <p14:creationId xmlns:p14="http://schemas.microsoft.com/office/powerpoint/2010/main" val="562453825"/>
+        <p14:creationId xmlns:p14="http://schemas.microsoft.com/office/powerpoint/2010/main" val="493933000"/>
       </p:ext>
     </p:extLst>
   </p:cSld>
 </p:sld>
 </file>
 
-<file path=ppt/slides/slide2.xml><?xml version="1.0" encoding="utf-8"?>
+<file path=ppt/slides/slide11.xml><?xml version="1.0" encoding="utf-8"?>
 <p:sld xmlns:p="http://schemas.openxmlformats.org/presentationml/2006/main">
   <p:cSld>
     <p:bg>
@@ -1867,7 +2001,7 @@
           <p:nvPr/>
         </p:nvPicPr>
         <p:blipFill>
-          <a:blip xmlns:r="http://schemas.openxmlformats.org/officeDocument/2006/relationships" xmlns:a="http://schemas.openxmlformats.org/drawingml/2006/main" r:embed="Ra64ccf722cc346f5"/>
+          <a:blip xmlns:r="http://schemas.openxmlformats.org/officeDocument/2006/relationships" xmlns:a="http://schemas.openxmlformats.org/drawingml/2006/main" r:embed="R032f118786a94456"/>
           <a:srcRect xmlns:a="http://schemas.openxmlformats.org/drawingml/2006/main" l="0" t="0" r="0" b="0"/>
           <a:stretch xmlns:a="http://schemas.openxmlformats.org/drawingml/2006/main">
             <a:fillRect l="0" t="0" r="0" b="0"/>
@@ -1886,14 +2020,14 @@
     </p:spTree>
     <p:extLst>
       <p:ext uri="{BB962C8B-B14F-4D97-AF65-F5344CB8AC3E}">
-        <p14:creationId xmlns:p14="http://schemas.microsoft.com/office/powerpoint/2010/main" val="1426453493"/>
+        <p14:creationId xmlns:p14="http://schemas.microsoft.com/office/powerpoint/2010/main" val="1660884827"/>
       </p:ext>
     </p:extLst>
   </p:cSld>
 </p:sld>
 </file>
 
-<file path=ppt/slides/slide3.xml><?xml version="1.0" encoding="utf-8"?>
+<file path=ppt/slides/slide12.xml><?xml version="1.0" encoding="utf-8"?>
 <p:sld xmlns:p="http://schemas.openxmlformats.org/presentationml/2006/main">
   <p:cSld>
     <p:bg>
@@ -1921,7 +2055,7 @@
           <p:nvPr/>
         </p:nvPicPr>
         <p:blipFill>
-          <a:blip xmlns:r="http://schemas.openxmlformats.org/officeDocument/2006/relationships" xmlns:a="http://schemas.openxmlformats.org/drawingml/2006/main" r:embed="R4bb3b01be0dc48cb"/>
+          <a:blip xmlns:r="http://schemas.openxmlformats.org/officeDocument/2006/relationships" xmlns:a="http://schemas.openxmlformats.org/drawingml/2006/main" r:embed="R127c976927a44a41"/>
           <a:srcRect xmlns:a="http://schemas.openxmlformats.org/drawingml/2006/main" l="0" t="0" r="0" b="0"/>
           <a:stretch xmlns:a="http://schemas.openxmlformats.org/drawingml/2006/main">
             <a:fillRect l="0" t="0" r="0" b="0"/>
@@ -1940,14 +2074,14 @@
     </p:spTree>
     <p:extLst>
       <p:ext uri="{BB962C8B-B14F-4D97-AF65-F5344CB8AC3E}">
-        <p14:creationId xmlns:p14="http://schemas.microsoft.com/office/powerpoint/2010/main" val="957809244"/>
+        <p14:creationId xmlns:p14="http://schemas.microsoft.com/office/powerpoint/2010/main" val="1218951708"/>
       </p:ext>
     </p:extLst>
   </p:cSld>
 </p:sld>
 </file>
 
-<file path=ppt/slides/slide4.xml><?xml version="1.0" encoding="utf-8"?>
+<file path=ppt/slides/slide2.xml><?xml version="1.0" encoding="utf-8"?>
 <p:sld xmlns:p="http://schemas.openxmlformats.org/presentationml/2006/main">
   <p:cSld>
     <p:bg>
@@ -1975,7 +2109,7 @@
           <p:nvPr/>
         </p:nvPicPr>
         <p:blipFill>
-          <a:blip xmlns:r="http://schemas.openxmlformats.org/officeDocument/2006/relationships" xmlns:a="http://schemas.openxmlformats.org/drawingml/2006/main" r:embed="R78b2690fd77d4c62"/>
+          <a:blip xmlns:r="http://schemas.openxmlformats.org/officeDocument/2006/relationships" xmlns:a="http://schemas.openxmlformats.org/drawingml/2006/main" r:embed="R31dbeed5dee94cde"/>
           <a:srcRect xmlns:a="http://schemas.openxmlformats.org/drawingml/2006/main" l="0" t="0" r="0" b="0"/>
           <a:stretch xmlns:a="http://schemas.openxmlformats.org/drawingml/2006/main">
             <a:fillRect l="0" t="0" r="0" b="0"/>
@@ -1994,14 +2128,14 @@
     </p:spTree>
     <p:extLst>
       <p:ext uri="{BB962C8B-B14F-4D97-AF65-F5344CB8AC3E}">
-        <p14:creationId xmlns:p14="http://schemas.microsoft.com/office/powerpoint/2010/main" val="1173091667"/>
+        <p14:creationId xmlns:p14="http://schemas.microsoft.com/office/powerpoint/2010/main" val="977968486"/>
       </p:ext>
     </p:extLst>
   </p:cSld>
 </p:sld>
 </file>
 
-<file path=ppt/slides/slide5.xml><?xml version="1.0" encoding="utf-8"?>
+<file path=ppt/slides/slide3.xml><?xml version="1.0" encoding="utf-8"?>
 <p:sld xmlns:p="http://schemas.openxmlformats.org/presentationml/2006/main">
   <p:cSld>
     <p:bg>
@@ -2029,7 +2163,7 @@
           <p:nvPr/>
         </p:nvPicPr>
         <p:blipFill>
-          <a:blip xmlns:r="http://schemas.openxmlformats.org/officeDocument/2006/relationships" xmlns:a="http://schemas.openxmlformats.org/drawingml/2006/main" r:embed="Rc757d1a4c37d4e7f"/>
+          <a:blip xmlns:r="http://schemas.openxmlformats.org/officeDocument/2006/relationships" xmlns:a="http://schemas.openxmlformats.org/drawingml/2006/main" r:embed="R0300ac300f9a4069"/>
           <a:srcRect xmlns:a="http://schemas.openxmlformats.org/drawingml/2006/main" l="0" t="0" r="0" b="0"/>
           <a:stretch xmlns:a="http://schemas.openxmlformats.org/drawingml/2006/main">
             <a:fillRect l="0" t="0" r="0" b="0"/>
@@ -2048,14 +2182,14 @@
     </p:spTree>
     <p:extLst>
       <p:ext uri="{BB962C8B-B14F-4D97-AF65-F5344CB8AC3E}">
-        <p14:creationId xmlns:p14="http://schemas.microsoft.com/office/powerpoint/2010/main" val="655865"/>
+        <p14:creationId xmlns:p14="http://schemas.microsoft.com/office/powerpoint/2010/main" val="82688240"/>
       </p:ext>
     </p:extLst>
   </p:cSld>
 </p:sld>
 </file>
 
-<file path=ppt/slides/slide6.xml><?xml version="1.0" encoding="utf-8"?>
+<file path=ppt/slides/slide4.xml><?xml version="1.0" encoding="utf-8"?>
 <p:sld xmlns:p="http://schemas.openxmlformats.org/presentationml/2006/main">
   <p:cSld>
     <p:bg>
@@ -2083,7 +2217,7 @@
           <p:nvPr/>
         </p:nvPicPr>
         <p:blipFill>
-          <a:blip xmlns:r="http://schemas.openxmlformats.org/officeDocument/2006/relationships" xmlns:a="http://schemas.openxmlformats.org/drawingml/2006/main" r:embed="Rc4afa14b43ec4a7b"/>
+          <a:blip xmlns:r="http://schemas.openxmlformats.org/officeDocument/2006/relationships" xmlns:a="http://schemas.openxmlformats.org/drawingml/2006/main" r:embed="R0565ac3e55bf4efb"/>
           <a:srcRect xmlns:a="http://schemas.openxmlformats.org/drawingml/2006/main" l="0" t="0" r="0" b="0"/>
           <a:stretch xmlns:a="http://schemas.openxmlformats.org/drawingml/2006/main">
             <a:fillRect l="0" t="0" r="0" b="0"/>
@@ -2102,14 +2236,14 @@
     </p:spTree>
     <p:extLst>
       <p:ext uri="{BB962C8B-B14F-4D97-AF65-F5344CB8AC3E}">
-        <p14:creationId xmlns:p14="http://schemas.microsoft.com/office/powerpoint/2010/main" val="469490363"/>
+        <p14:creationId xmlns:p14="http://schemas.microsoft.com/office/powerpoint/2010/main" val="1153317619"/>
       </p:ext>
     </p:extLst>
   </p:cSld>
 </p:sld>
 </file>
 
-<file path=ppt/slides/slide7.xml><?xml version="1.0" encoding="utf-8"?>
+<file path=ppt/slides/slide5.xml><?xml version="1.0" encoding="utf-8"?>
 <p:sld xmlns:p="http://schemas.openxmlformats.org/presentationml/2006/main">
   <p:cSld>
     <p:bg>
@@ -2137,7 +2271,7 @@
           <p:nvPr/>
         </p:nvPicPr>
         <p:blipFill>
-          <a:blip xmlns:r="http://schemas.openxmlformats.org/officeDocument/2006/relationships" xmlns:a="http://schemas.openxmlformats.org/drawingml/2006/main" r:embed="Raa8065b12fc0424c"/>
+          <a:blip xmlns:r="http://schemas.openxmlformats.org/officeDocument/2006/relationships" xmlns:a="http://schemas.openxmlformats.org/drawingml/2006/main" r:embed="R879cf97787ea41bf"/>
           <a:srcRect xmlns:a="http://schemas.openxmlformats.org/drawingml/2006/main" l="0" t="0" r="0" b="0"/>
           <a:stretch xmlns:a="http://schemas.openxmlformats.org/drawingml/2006/main">
             <a:fillRect l="0" t="0" r="0" b="0"/>
@@ -2156,14 +2290,14 @@
     </p:spTree>
     <p:extLst>
       <p:ext uri="{BB962C8B-B14F-4D97-AF65-F5344CB8AC3E}">
-        <p14:creationId xmlns:p14="http://schemas.microsoft.com/office/powerpoint/2010/main" val="723904353"/>
+        <p14:creationId xmlns:p14="http://schemas.microsoft.com/office/powerpoint/2010/main" val="1470943791"/>
       </p:ext>
     </p:extLst>
   </p:cSld>
 </p:sld>
 </file>
 
-<file path=ppt/slides/slide8.xml><?xml version="1.0" encoding="utf-8"?>
+<file path=ppt/slides/slide6.xml><?xml version="1.0" encoding="utf-8"?>
 <p:sld xmlns:p="http://schemas.openxmlformats.org/presentationml/2006/main">
   <p:cSld>
     <p:bg>
@@ -2191,7 +2325,7 @@
           <p:nvPr/>
         </p:nvPicPr>
         <p:blipFill>
-          <a:blip xmlns:r="http://schemas.openxmlformats.org/officeDocument/2006/relationships" xmlns:a="http://schemas.openxmlformats.org/drawingml/2006/main" r:embed="R6470c9ccdb0c4a55"/>
+          <a:blip xmlns:r="http://schemas.openxmlformats.org/officeDocument/2006/relationships" xmlns:a="http://schemas.openxmlformats.org/drawingml/2006/main" r:embed="Rb1f3a3b374ec4b2c"/>
           <a:srcRect xmlns:a="http://schemas.openxmlformats.org/drawingml/2006/main" l="0" t="0" r="0" b="0"/>
           <a:stretch xmlns:a="http://schemas.openxmlformats.org/drawingml/2006/main">
             <a:fillRect l="0" t="0" r="0" b="0"/>
@@ -2210,14 +2344,14 @@
     </p:spTree>
     <p:extLst>
       <p:ext uri="{BB962C8B-B14F-4D97-AF65-F5344CB8AC3E}">
-        <p14:creationId xmlns:p14="http://schemas.microsoft.com/office/powerpoint/2010/main" val="206547577"/>
+        <p14:creationId xmlns:p14="http://schemas.microsoft.com/office/powerpoint/2010/main" val="1774910196"/>
       </p:ext>
     </p:extLst>
   </p:cSld>
 </p:sld>
 </file>
 
-<file path=ppt/slides/slide9.xml><?xml version="1.0" encoding="utf-8"?>
+<file path=ppt/slides/slide7.xml><?xml version="1.0" encoding="utf-8"?>
 <p:sld xmlns:p="http://schemas.openxmlformats.org/presentationml/2006/main">
   <p:cSld>
     <p:bg>
@@ -2245,7 +2379,7 @@
           <p:nvPr/>
         </p:nvPicPr>
         <p:blipFill>
-          <a:blip xmlns:r="http://schemas.openxmlformats.org/officeDocument/2006/relationships" xmlns:a="http://schemas.openxmlformats.org/drawingml/2006/main" r:embed="Ra901ceb8f88c4e8a"/>
+          <a:blip xmlns:r="http://schemas.openxmlformats.org/officeDocument/2006/relationships" xmlns:a="http://schemas.openxmlformats.org/drawingml/2006/main" r:embed="R3098ec886d744d78"/>
           <a:srcRect xmlns:a="http://schemas.openxmlformats.org/drawingml/2006/main" l="0" t="0" r="0" b="0"/>
           <a:stretch xmlns:a="http://schemas.openxmlformats.org/drawingml/2006/main">
             <a:fillRect l="0" t="0" r="0" b="0"/>
@@ -2264,7 +2398,115 @@
     </p:spTree>
     <p:extLst>
       <p:ext uri="{BB962C8B-B14F-4D97-AF65-F5344CB8AC3E}">
-        <p14:creationId xmlns:p14="http://schemas.microsoft.com/office/powerpoint/2010/main" val="215744087"/>
+        <p14:creationId xmlns:p14="http://schemas.microsoft.com/office/powerpoint/2010/main" val="1557831620"/>
+      </p:ext>
+    </p:extLst>
+  </p:cSld>
+</p:sld>
+</file>
+
+<file path=ppt/slides/slide8.xml><?xml version="1.0" encoding="utf-8"?>
+<p:sld xmlns:p="http://schemas.openxmlformats.org/presentationml/2006/main">
+  <p:cSld>
+    <p:bg>
+      <p:bgPr>
+        <a:solidFill xmlns:a="http://schemas.openxmlformats.org/drawingml/2006/main">
+          <a:srgbClr val="FAFAF8"/>
+        </a:solidFill>
+      </p:bgPr>
+    </p:bg>
+    <p:spTree>
+      <p:nvGrpSpPr>
+        <p:cNvPr id="1" name=""/>
+        <p:cNvGrpSpPr/>
+        <p:nvPr/>
+      </p:nvGrpSpPr>
+      <p:grpSpPr>
+        <a:xfrm xmlns:a="http://schemas.openxmlformats.org/drawingml/2006/main"/>
+      </p:grpSpPr>
+      <p:pic>
+        <p:nvPicPr>
+          <p:cNvPr id="2" name=""/>
+          <p:cNvPicPr>
+            <a:picLocks xmlns:a="http://schemas.openxmlformats.org/drawingml/2006/main" noChangeAspect="1"/>
+          </p:cNvPicPr>
+          <p:nvPr/>
+        </p:nvPicPr>
+        <p:blipFill>
+          <a:blip xmlns:r="http://schemas.openxmlformats.org/officeDocument/2006/relationships" xmlns:a="http://schemas.openxmlformats.org/drawingml/2006/main" r:embed="Rdae2b159fd9340dd"/>
+          <a:srcRect xmlns:a="http://schemas.openxmlformats.org/drawingml/2006/main" l="0" t="0" r="0" b="0"/>
+          <a:stretch xmlns:a="http://schemas.openxmlformats.org/drawingml/2006/main">
+            <a:fillRect l="0" t="0" r="0" b="0"/>
+          </a:stretch>
+        </p:blipFill>
+        <p:spPr>
+          <a:xfrm xmlns:a="http://schemas.openxmlformats.org/drawingml/2006/main">
+            <a:off x="0" y="0"/>
+            <a:ext cx="12192000" cy="6858000"/>
+          </a:xfrm>
+          <a:prstGeom xmlns:a="http://schemas.openxmlformats.org/drawingml/2006/main" prst="rect">
+            <a:avLst/>
+          </a:prstGeom>
+        </p:spPr>
+      </p:pic>
+    </p:spTree>
+    <p:extLst>
+      <p:ext uri="{BB962C8B-B14F-4D97-AF65-F5344CB8AC3E}">
+        <p14:creationId xmlns:p14="http://schemas.microsoft.com/office/powerpoint/2010/main" val="620352547"/>
+      </p:ext>
+    </p:extLst>
+  </p:cSld>
+</p:sld>
+</file>
+
+<file path=ppt/slides/slide9.xml><?xml version="1.0" encoding="utf-8"?>
+<p:sld xmlns:p="http://schemas.openxmlformats.org/presentationml/2006/main">
+  <p:cSld>
+    <p:bg>
+      <p:bgPr>
+        <a:solidFill xmlns:a="http://schemas.openxmlformats.org/drawingml/2006/main">
+          <a:srgbClr val="FAFAF8"/>
+        </a:solidFill>
+      </p:bgPr>
+    </p:bg>
+    <p:spTree>
+      <p:nvGrpSpPr>
+        <p:cNvPr id="1" name=""/>
+        <p:cNvGrpSpPr/>
+        <p:nvPr/>
+      </p:nvGrpSpPr>
+      <p:grpSpPr>
+        <a:xfrm xmlns:a="http://schemas.openxmlformats.org/drawingml/2006/main"/>
+      </p:grpSpPr>
+      <p:pic>
+        <p:nvPicPr>
+          <p:cNvPr id="2" name=""/>
+          <p:cNvPicPr>
+            <a:picLocks xmlns:a="http://schemas.openxmlformats.org/drawingml/2006/main" noChangeAspect="1"/>
+          </p:cNvPicPr>
+          <p:nvPr/>
+        </p:nvPicPr>
+        <p:blipFill>
+          <a:blip xmlns:r="http://schemas.openxmlformats.org/officeDocument/2006/relationships" xmlns:a="http://schemas.openxmlformats.org/drawingml/2006/main" r:embed="R30d8ba2f1d72459b"/>
+          <a:srcRect xmlns:a="http://schemas.openxmlformats.org/drawingml/2006/main" l="0" t="0" r="0" b="0"/>
+          <a:stretch xmlns:a="http://schemas.openxmlformats.org/drawingml/2006/main">
+            <a:fillRect l="0" t="0" r="0" b="0"/>
+          </a:stretch>
+        </p:blipFill>
+        <p:spPr>
+          <a:xfrm xmlns:a="http://schemas.openxmlformats.org/drawingml/2006/main">
+            <a:off x="0" y="0"/>
+            <a:ext cx="12192000" cy="6858000"/>
+          </a:xfrm>
+          <a:prstGeom xmlns:a="http://schemas.openxmlformats.org/drawingml/2006/main" prst="rect">
+            <a:avLst/>
+          </a:prstGeom>
+        </p:spPr>
+      </p:pic>
+    </p:spTree>
+    <p:extLst>
+      <p:ext uri="{BB962C8B-B14F-4D97-AF65-F5344CB8AC3E}">
+        <p14:creationId xmlns:p14="http://schemas.microsoft.com/office/powerpoint/2010/main" val="1574891851"/>
       </p:ext>
     </p:extLst>
   </p:cSld>

</xml_diff>

<commit_message>
Update documentation and enhance contract audit workflow with new metrics and improved clarity. Key changes include updated token savings data reflecting a 25.2% reduction, detailed results from real-world contract audits, and refined presentation materials for the Feishu closed-loop integration. Additionally, adjustments were made to the README and competition guide to reflect these enhancements. Co-authored-by: Cursor <cursoragent@cursor.com>
</commit_message>
<xml_diff>
--- a/outputs/opc-demo/ppt/opc-xiaohuanxiong-workflow-submission.pptx
+++ b/outputs/opc-demo/ppt/opc-xiaohuanxiong-workflow-submission.pptx
@@ -2,24 +2,22 @@
 <file path=ppt/presentation.xml><?xml version="1.0" encoding="utf-8"?>
 <p:presentation xmlns:p="http://schemas.openxmlformats.org/presentationml/2006/main">
   <p:sldMasterIdLst>
-    <p:sldMasterId xmlns:r="http://schemas.openxmlformats.org/officeDocument/2006/relationships" id="2147483648" r:id="Re238ada9f7624c2c"/>
+    <p:sldMasterId xmlns:r="http://schemas.openxmlformats.org/officeDocument/2006/relationships" id="2147483648" r:id="R57659826143e45be"/>
   </p:sldMasterIdLst>
   <p:notesMasterIdLst>
-    <p:notesMasterId xmlns:r="http://schemas.openxmlformats.org/officeDocument/2006/relationships" r:id="Rdaa40abaed3d4ee6"/>
+    <p:notesMasterId xmlns:r="http://schemas.openxmlformats.org/officeDocument/2006/relationships" r:id="Re7130799bdc14520"/>
   </p:notesMasterIdLst>
   <p:sldIdLst>
-    <p:sldId xmlns:r="http://schemas.openxmlformats.org/officeDocument/2006/relationships" id="256" r:id="Rb3823f609271469d"/>
-    <p:sldId xmlns:r="http://schemas.openxmlformats.org/officeDocument/2006/relationships" id="257" r:id="Rdc21c21223ea45b3"/>
-    <p:sldId xmlns:r="http://schemas.openxmlformats.org/officeDocument/2006/relationships" id="258" r:id="R3b9a2887114c484d"/>
-    <p:sldId xmlns:r="http://schemas.openxmlformats.org/officeDocument/2006/relationships" id="259" r:id="Rcbd8e7cfb8f1454d"/>
-    <p:sldId xmlns:r="http://schemas.openxmlformats.org/officeDocument/2006/relationships" id="260" r:id="R9b1d6051afe74136"/>
-    <p:sldId xmlns:r="http://schemas.openxmlformats.org/officeDocument/2006/relationships" id="261" r:id="R5303e0cab133443f"/>
-    <p:sldId xmlns:r="http://schemas.openxmlformats.org/officeDocument/2006/relationships" id="262" r:id="R3e896448f0c14468"/>
-    <p:sldId xmlns:r="http://schemas.openxmlformats.org/officeDocument/2006/relationships" id="263" r:id="R6c9df94211094232"/>
-    <p:sldId xmlns:r="http://schemas.openxmlformats.org/officeDocument/2006/relationships" id="264" r:id="Rf79a39d1a2f24817"/>
-    <p:sldId xmlns:r="http://schemas.openxmlformats.org/officeDocument/2006/relationships" id="265" r:id="R1ab919669d144fe4"/>
-    <p:sldId xmlns:r="http://schemas.openxmlformats.org/officeDocument/2006/relationships" id="266" r:id="R24032efe51e74445"/>
-    <p:sldId xmlns:r="http://schemas.openxmlformats.org/officeDocument/2006/relationships" id="267" r:id="R653cee51507a4dda"/>
+    <p:sldId xmlns:r="http://schemas.openxmlformats.org/officeDocument/2006/relationships" id="256" r:id="R215a4afecbaa4f4f"/>
+    <p:sldId xmlns:r="http://schemas.openxmlformats.org/officeDocument/2006/relationships" id="257" r:id="R7086d4e0fc834cf7"/>
+    <p:sldId xmlns:r="http://schemas.openxmlformats.org/officeDocument/2006/relationships" id="258" r:id="R1ceb4eab53e74d7b"/>
+    <p:sldId xmlns:r="http://schemas.openxmlformats.org/officeDocument/2006/relationships" id="259" r:id="R11a5365ec1734398"/>
+    <p:sldId xmlns:r="http://schemas.openxmlformats.org/officeDocument/2006/relationships" id="260" r:id="R3bd0ec5080f441dd"/>
+    <p:sldId xmlns:r="http://schemas.openxmlformats.org/officeDocument/2006/relationships" id="261" r:id="Rb298fbb650a043af"/>
+    <p:sldId xmlns:r="http://schemas.openxmlformats.org/officeDocument/2006/relationships" id="262" r:id="Rf8fc59a590344fec"/>
+    <p:sldId xmlns:r="http://schemas.openxmlformats.org/officeDocument/2006/relationships" id="263" r:id="Rd094c96df0d04c8c"/>
+    <p:sldId xmlns:r="http://schemas.openxmlformats.org/officeDocument/2006/relationships" id="264" r:id="R348cffaaf3b5490d"/>
+    <p:sldId xmlns:r="http://schemas.openxmlformats.org/officeDocument/2006/relationships" id="265" r:id="Rec732355cc1c48cd"/>
   </p:sldIdLst>
   <p:sldSz cx="12192000" cy="6858000"/>
   <p:notesSz cx="6858000" cy="9144000"/>
@@ -640,138 +638,6 @@
 </p:notes>
 </file>
 
-<file path=ppt/notesSlides/notesSlide11.xml><?xml version="1.0" encoding="utf-8"?>
-<p:notes xmlns:p="http://schemas.openxmlformats.org/presentationml/2006/main">
-  <p:cSld>
-    <p:spTree>
-      <p:nvGrpSpPr>
-        <p:cNvPr id="1" name=""/>
-        <p:cNvGrpSpPr/>
-        <p:nvPr/>
-      </p:nvGrpSpPr>
-      <p:grpSpPr>
-        <a:xfrm xmlns:a="http://schemas.openxmlformats.org/drawingml/2006/main"/>
-      </p:grpSpPr>
-      <p:sp>
-        <p:nvSpPr>
-          <p:cNvPr id="2" name="Slide Image Placeholder 1"/>
-          <p:cNvSpPr>
-            <a:spLocks xmlns:a="http://schemas.openxmlformats.org/drawingml/2006/main" noGrp="1"/>
-          </p:cNvSpPr>
-          <p:nvPr>
-            <p:ph type="sldImg" idx="0"/>
-          </p:nvPr>
-        </p:nvSpPr>
-        <p:spPr/>
-      </p:sp>
-      <p:sp>
-        <p:nvSpPr>
-          <p:cNvPr id="3" name="Notes Placeholder 2"/>
-          <p:cNvSpPr>
-            <a:spLocks xmlns:a="http://schemas.openxmlformats.org/drawingml/2006/main" noGrp="1"/>
-          </p:cNvSpPr>
-          <p:nvPr>
-            <p:ph type="body" idx="1"/>
-          </p:nvPr>
-        </p:nvSpPr>
-        <p:spPr/>
-        <p:txBody>
-          <a:bodyPr xmlns:a="http://schemas.openxmlformats.org/drawingml/2006/main"/>
-          <a:lstStyle xmlns:a="http://schemas.openxmlformats.org/drawingml/2006/main"/>
-          <a:p xmlns:a="http://schemas.openxmlformats.org/drawingml/2006/main"/>
-        </p:txBody>
-      </p:sp>
-      <p:sp>
-        <p:nvSpPr>
-          <p:cNvPr id="4" name="Slide Number Placeholder 3"/>
-          <p:cNvSpPr>
-            <a:spLocks xmlns:a="http://schemas.openxmlformats.org/drawingml/2006/main" noGrp="1"/>
-          </p:cNvSpPr>
-          <p:nvPr>
-            <p:ph type="sldNum" idx="5"/>
-          </p:nvPr>
-        </p:nvSpPr>
-        <p:spPr/>
-        <p:txBody>
-          <a:bodyPr xmlns:a="http://schemas.openxmlformats.org/drawingml/2006/main"/>
-          <a:lstStyle xmlns:a="http://schemas.openxmlformats.org/drawingml/2006/main"/>
-          <a:p xmlns:a="http://schemas.openxmlformats.org/drawingml/2006/main"/>
-        </p:txBody>
-      </p:sp>
-    </p:spTree>
-  </p:cSld>
-  <p:clrMapOvr>
-    <a:masterClrMapping xmlns:a="http://schemas.openxmlformats.org/drawingml/2006/main"/>
-  </p:clrMapOvr>
-</p:notes>
-</file>
-
-<file path=ppt/notesSlides/notesSlide12.xml><?xml version="1.0" encoding="utf-8"?>
-<p:notes xmlns:p="http://schemas.openxmlformats.org/presentationml/2006/main">
-  <p:cSld>
-    <p:spTree>
-      <p:nvGrpSpPr>
-        <p:cNvPr id="1" name=""/>
-        <p:cNvGrpSpPr/>
-        <p:nvPr/>
-      </p:nvGrpSpPr>
-      <p:grpSpPr>
-        <a:xfrm xmlns:a="http://schemas.openxmlformats.org/drawingml/2006/main"/>
-      </p:grpSpPr>
-      <p:sp>
-        <p:nvSpPr>
-          <p:cNvPr id="2" name="Slide Image Placeholder 1"/>
-          <p:cNvSpPr>
-            <a:spLocks xmlns:a="http://schemas.openxmlformats.org/drawingml/2006/main" noGrp="1"/>
-          </p:cNvSpPr>
-          <p:nvPr>
-            <p:ph type="sldImg" idx="0"/>
-          </p:nvPr>
-        </p:nvSpPr>
-        <p:spPr/>
-      </p:sp>
-      <p:sp>
-        <p:nvSpPr>
-          <p:cNvPr id="3" name="Notes Placeholder 2"/>
-          <p:cNvSpPr>
-            <a:spLocks xmlns:a="http://schemas.openxmlformats.org/drawingml/2006/main" noGrp="1"/>
-          </p:cNvSpPr>
-          <p:nvPr>
-            <p:ph type="body" idx="1"/>
-          </p:nvPr>
-        </p:nvSpPr>
-        <p:spPr/>
-        <p:txBody>
-          <a:bodyPr xmlns:a="http://schemas.openxmlformats.org/drawingml/2006/main"/>
-          <a:lstStyle xmlns:a="http://schemas.openxmlformats.org/drawingml/2006/main"/>
-          <a:p xmlns:a="http://schemas.openxmlformats.org/drawingml/2006/main"/>
-        </p:txBody>
-      </p:sp>
-      <p:sp>
-        <p:nvSpPr>
-          <p:cNvPr id="4" name="Slide Number Placeholder 3"/>
-          <p:cNvSpPr>
-            <a:spLocks xmlns:a="http://schemas.openxmlformats.org/drawingml/2006/main" noGrp="1"/>
-          </p:cNvSpPr>
-          <p:nvPr>
-            <p:ph type="sldNum" idx="5"/>
-          </p:nvPr>
-        </p:nvSpPr>
-        <p:spPr/>
-        <p:txBody>
-          <a:bodyPr xmlns:a="http://schemas.openxmlformats.org/drawingml/2006/main"/>
-          <a:lstStyle xmlns:a="http://schemas.openxmlformats.org/drawingml/2006/main"/>
-          <a:p xmlns:a="http://schemas.openxmlformats.org/drawingml/2006/main"/>
-        </p:txBody>
-      </p:sp>
-    </p:spTree>
-  </p:cSld>
-  <p:clrMapOvr>
-    <a:masterClrMapping xmlns:a="http://schemas.openxmlformats.org/drawingml/2006/main"/>
-  </p:clrMapOvr>
-</p:notes>
-</file>
-
 <file path=ppt/notesSlides/notesSlide2.xml><?xml version="1.0" encoding="utf-8"?>
 <p:notes xmlns:p="http://schemas.openxmlformats.org/presentationml/2006/main">
   <p:cSld>
@@ -1338,7 +1204,7 @@
   </p:cSld>
   <p:clrMap bg1="lt1" tx1="dk1" bg2="lt2" tx2="dk2" accent1="accent1" accent2="accent2" accent3="accent3" accent4="accent4" accent5="accent5" accent6="accent6" hlink="hlink" folHlink="folHlink"/>
   <p:sldLayoutIdLst>
-    <p:sldLayoutId xmlns:r="http://schemas.openxmlformats.org/officeDocument/2006/relationships" id="2147483649" r:id="R81b9627f54c34ad8"/>
+    <p:sldLayoutId xmlns:r="http://schemas.openxmlformats.org/officeDocument/2006/relationships" id="2147483649" r:id="R9cfed1dc0d214beb"/>
   </p:sldLayoutIdLst>
   <p:txStyles>
     <p:titleStyle>
@@ -1893,7 +1759,7 @@
           <p:nvPr/>
         </p:nvPicPr>
         <p:blipFill>
-          <a:blip xmlns:r="http://schemas.openxmlformats.org/officeDocument/2006/relationships" xmlns:a="http://schemas.openxmlformats.org/drawingml/2006/main" r:embed="Rc2581216b3fc472d"/>
+          <a:blip xmlns:r="http://schemas.openxmlformats.org/officeDocument/2006/relationships" xmlns:a="http://schemas.openxmlformats.org/drawingml/2006/main" r:embed="R6d0db04111e943f2"/>
           <a:srcRect xmlns:a="http://schemas.openxmlformats.org/drawingml/2006/main" l="0" t="0" r="0" b="0"/>
           <a:stretch xmlns:a="http://schemas.openxmlformats.org/drawingml/2006/main">
             <a:fillRect l="0" t="0" r="0" b="0"/>
@@ -1912,7 +1778,7 @@
     </p:spTree>
     <p:extLst>
       <p:ext uri="{BB962C8B-B14F-4D97-AF65-F5344CB8AC3E}">
-        <p14:creationId xmlns:p14="http://schemas.microsoft.com/office/powerpoint/2010/main" val="1187767200"/>
+        <p14:creationId xmlns:p14="http://schemas.microsoft.com/office/powerpoint/2010/main" val="864867943"/>
       </p:ext>
     </p:extLst>
   </p:cSld>
@@ -1947,7 +1813,7 @@
           <p:nvPr/>
         </p:nvPicPr>
         <p:blipFill>
-          <a:blip xmlns:r="http://schemas.openxmlformats.org/officeDocument/2006/relationships" xmlns:a="http://schemas.openxmlformats.org/drawingml/2006/main" r:embed="Rb0f62dbdb85842b4"/>
+          <a:blip xmlns:r="http://schemas.openxmlformats.org/officeDocument/2006/relationships" xmlns:a="http://schemas.openxmlformats.org/drawingml/2006/main" r:embed="Rb3c8645135a44edf"/>
           <a:srcRect xmlns:a="http://schemas.openxmlformats.org/drawingml/2006/main" l="0" t="0" r="0" b="0"/>
           <a:stretch xmlns:a="http://schemas.openxmlformats.org/drawingml/2006/main">
             <a:fillRect l="0" t="0" r="0" b="0"/>
@@ -1966,14 +1832,14 @@
     </p:spTree>
     <p:extLst>
       <p:ext uri="{BB962C8B-B14F-4D97-AF65-F5344CB8AC3E}">
-        <p14:creationId xmlns:p14="http://schemas.microsoft.com/office/powerpoint/2010/main" val="493933000"/>
+        <p14:creationId xmlns:p14="http://schemas.microsoft.com/office/powerpoint/2010/main" val="1868673146"/>
       </p:ext>
     </p:extLst>
   </p:cSld>
 </p:sld>
 </file>
 
-<file path=ppt/slides/slide11.xml><?xml version="1.0" encoding="utf-8"?>
+<file path=ppt/slides/slide2.xml><?xml version="1.0" encoding="utf-8"?>
 <p:sld xmlns:p="http://schemas.openxmlformats.org/presentationml/2006/main">
   <p:cSld>
     <p:bg>
@@ -2001,7 +1867,7 @@
           <p:nvPr/>
         </p:nvPicPr>
         <p:blipFill>
-          <a:blip xmlns:r="http://schemas.openxmlformats.org/officeDocument/2006/relationships" xmlns:a="http://schemas.openxmlformats.org/drawingml/2006/main" r:embed="R032f118786a94456"/>
+          <a:blip xmlns:r="http://schemas.openxmlformats.org/officeDocument/2006/relationships" xmlns:a="http://schemas.openxmlformats.org/drawingml/2006/main" r:embed="R7f4ff617ec8b4e85"/>
           <a:srcRect xmlns:a="http://schemas.openxmlformats.org/drawingml/2006/main" l="0" t="0" r="0" b="0"/>
           <a:stretch xmlns:a="http://schemas.openxmlformats.org/drawingml/2006/main">
             <a:fillRect l="0" t="0" r="0" b="0"/>
@@ -2020,14 +1886,14 @@
     </p:spTree>
     <p:extLst>
       <p:ext uri="{BB962C8B-B14F-4D97-AF65-F5344CB8AC3E}">
-        <p14:creationId xmlns:p14="http://schemas.microsoft.com/office/powerpoint/2010/main" val="1660884827"/>
+        <p14:creationId xmlns:p14="http://schemas.microsoft.com/office/powerpoint/2010/main" val="147837892"/>
       </p:ext>
     </p:extLst>
   </p:cSld>
 </p:sld>
 </file>
 
-<file path=ppt/slides/slide12.xml><?xml version="1.0" encoding="utf-8"?>
+<file path=ppt/slides/slide3.xml><?xml version="1.0" encoding="utf-8"?>
 <p:sld xmlns:p="http://schemas.openxmlformats.org/presentationml/2006/main">
   <p:cSld>
     <p:bg>
@@ -2055,7 +1921,7 @@
           <p:nvPr/>
         </p:nvPicPr>
         <p:blipFill>
-          <a:blip xmlns:r="http://schemas.openxmlformats.org/officeDocument/2006/relationships" xmlns:a="http://schemas.openxmlformats.org/drawingml/2006/main" r:embed="R127c976927a44a41"/>
+          <a:blip xmlns:r="http://schemas.openxmlformats.org/officeDocument/2006/relationships" xmlns:a="http://schemas.openxmlformats.org/drawingml/2006/main" r:embed="Rd08d055f09834af7"/>
           <a:srcRect xmlns:a="http://schemas.openxmlformats.org/drawingml/2006/main" l="0" t="0" r="0" b="0"/>
           <a:stretch xmlns:a="http://schemas.openxmlformats.org/drawingml/2006/main">
             <a:fillRect l="0" t="0" r="0" b="0"/>
@@ -2074,14 +1940,14 @@
     </p:spTree>
     <p:extLst>
       <p:ext uri="{BB962C8B-B14F-4D97-AF65-F5344CB8AC3E}">
-        <p14:creationId xmlns:p14="http://schemas.microsoft.com/office/powerpoint/2010/main" val="1218951708"/>
+        <p14:creationId xmlns:p14="http://schemas.microsoft.com/office/powerpoint/2010/main" val="403988038"/>
       </p:ext>
     </p:extLst>
   </p:cSld>
 </p:sld>
 </file>
 
-<file path=ppt/slides/slide2.xml><?xml version="1.0" encoding="utf-8"?>
+<file path=ppt/slides/slide4.xml><?xml version="1.0" encoding="utf-8"?>
 <p:sld xmlns:p="http://schemas.openxmlformats.org/presentationml/2006/main">
   <p:cSld>
     <p:bg>
@@ -2109,7 +1975,7 @@
           <p:nvPr/>
         </p:nvPicPr>
         <p:blipFill>
-          <a:blip xmlns:r="http://schemas.openxmlformats.org/officeDocument/2006/relationships" xmlns:a="http://schemas.openxmlformats.org/drawingml/2006/main" r:embed="R31dbeed5dee94cde"/>
+          <a:blip xmlns:r="http://schemas.openxmlformats.org/officeDocument/2006/relationships" xmlns:a="http://schemas.openxmlformats.org/drawingml/2006/main" r:embed="Ra88894fc27c841a4"/>
           <a:srcRect xmlns:a="http://schemas.openxmlformats.org/drawingml/2006/main" l="0" t="0" r="0" b="0"/>
           <a:stretch xmlns:a="http://schemas.openxmlformats.org/drawingml/2006/main">
             <a:fillRect l="0" t="0" r="0" b="0"/>
@@ -2128,14 +1994,14 @@
     </p:spTree>
     <p:extLst>
       <p:ext uri="{BB962C8B-B14F-4D97-AF65-F5344CB8AC3E}">
-        <p14:creationId xmlns:p14="http://schemas.microsoft.com/office/powerpoint/2010/main" val="977968486"/>
+        <p14:creationId xmlns:p14="http://schemas.microsoft.com/office/powerpoint/2010/main" val="1618278368"/>
       </p:ext>
     </p:extLst>
   </p:cSld>
 </p:sld>
 </file>
 
-<file path=ppt/slides/slide3.xml><?xml version="1.0" encoding="utf-8"?>
+<file path=ppt/slides/slide5.xml><?xml version="1.0" encoding="utf-8"?>
 <p:sld xmlns:p="http://schemas.openxmlformats.org/presentationml/2006/main">
   <p:cSld>
     <p:bg>
@@ -2163,7 +2029,7 @@
           <p:nvPr/>
         </p:nvPicPr>
         <p:blipFill>
-          <a:blip xmlns:r="http://schemas.openxmlformats.org/officeDocument/2006/relationships" xmlns:a="http://schemas.openxmlformats.org/drawingml/2006/main" r:embed="R0300ac300f9a4069"/>
+          <a:blip xmlns:r="http://schemas.openxmlformats.org/officeDocument/2006/relationships" xmlns:a="http://schemas.openxmlformats.org/drawingml/2006/main" r:embed="Raa98a5baf8d74d88"/>
           <a:srcRect xmlns:a="http://schemas.openxmlformats.org/drawingml/2006/main" l="0" t="0" r="0" b="0"/>
           <a:stretch xmlns:a="http://schemas.openxmlformats.org/drawingml/2006/main">
             <a:fillRect l="0" t="0" r="0" b="0"/>
@@ -2182,14 +2048,14 @@
     </p:spTree>
     <p:extLst>
       <p:ext uri="{BB962C8B-B14F-4D97-AF65-F5344CB8AC3E}">
-        <p14:creationId xmlns:p14="http://schemas.microsoft.com/office/powerpoint/2010/main" val="82688240"/>
+        <p14:creationId xmlns:p14="http://schemas.microsoft.com/office/powerpoint/2010/main" val="364977371"/>
       </p:ext>
     </p:extLst>
   </p:cSld>
 </p:sld>
 </file>
 
-<file path=ppt/slides/slide4.xml><?xml version="1.0" encoding="utf-8"?>
+<file path=ppt/slides/slide6.xml><?xml version="1.0" encoding="utf-8"?>
 <p:sld xmlns:p="http://schemas.openxmlformats.org/presentationml/2006/main">
   <p:cSld>
     <p:bg>
@@ -2217,7 +2083,7 @@
           <p:nvPr/>
         </p:nvPicPr>
         <p:blipFill>
-          <a:blip xmlns:r="http://schemas.openxmlformats.org/officeDocument/2006/relationships" xmlns:a="http://schemas.openxmlformats.org/drawingml/2006/main" r:embed="R0565ac3e55bf4efb"/>
+          <a:blip xmlns:r="http://schemas.openxmlformats.org/officeDocument/2006/relationships" xmlns:a="http://schemas.openxmlformats.org/drawingml/2006/main" r:embed="Rd9c1a8344a0942dd"/>
           <a:srcRect xmlns:a="http://schemas.openxmlformats.org/drawingml/2006/main" l="0" t="0" r="0" b="0"/>
           <a:stretch xmlns:a="http://schemas.openxmlformats.org/drawingml/2006/main">
             <a:fillRect l="0" t="0" r="0" b="0"/>
@@ -2236,14 +2102,14 @@
     </p:spTree>
     <p:extLst>
       <p:ext uri="{BB962C8B-B14F-4D97-AF65-F5344CB8AC3E}">
-        <p14:creationId xmlns:p14="http://schemas.microsoft.com/office/powerpoint/2010/main" val="1153317619"/>
+        <p14:creationId xmlns:p14="http://schemas.microsoft.com/office/powerpoint/2010/main" val="1414934595"/>
       </p:ext>
     </p:extLst>
   </p:cSld>
 </p:sld>
 </file>
 
-<file path=ppt/slides/slide5.xml><?xml version="1.0" encoding="utf-8"?>
+<file path=ppt/slides/slide7.xml><?xml version="1.0" encoding="utf-8"?>
 <p:sld xmlns:p="http://schemas.openxmlformats.org/presentationml/2006/main">
   <p:cSld>
     <p:bg>
@@ -2271,7 +2137,7 @@
           <p:nvPr/>
         </p:nvPicPr>
         <p:blipFill>
-          <a:blip xmlns:r="http://schemas.openxmlformats.org/officeDocument/2006/relationships" xmlns:a="http://schemas.openxmlformats.org/drawingml/2006/main" r:embed="R879cf97787ea41bf"/>
+          <a:blip xmlns:r="http://schemas.openxmlformats.org/officeDocument/2006/relationships" xmlns:a="http://schemas.openxmlformats.org/drawingml/2006/main" r:embed="R9586c1b3d5374ef8"/>
           <a:srcRect xmlns:a="http://schemas.openxmlformats.org/drawingml/2006/main" l="0" t="0" r="0" b="0"/>
           <a:stretch xmlns:a="http://schemas.openxmlformats.org/drawingml/2006/main">
             <a:fillRect l="0" t="0" r="0" b="0"/>
@@ -2290,14 +2156,14 @@
     </p:spTree>
     <p:extLst>
       <p:ext uri="{BB962C8B-B14F-4D97-AF65-F5344CB8AC3E}">
-        <p14:creationId xmlns:p14="http://schemas.microsoft.com/office/powerpoint/2010/main" val="1470943791"/>
+        <p14:creationId xmlns:p14="http://schemas.microsoft.com/office/powerpoint/2010/main" val="1562121016"/>
       </p:ext>
     </p:extLst>
   </p:cSld>
 </p:sld>
 </file>
 
-<file path=ppt/slides/slide6.xml><?xml version="1.0" encoding="utf-8"?>
+<file path=ppt/slides/slide8.xml><?xml version="1.0" encoding="utf-8"?>
 <p:sld xmlns:p="http://schemas.openxmlformats.org/presentationml/2006/main">
   <p:cSld>
     <p:bg>
@@ -2325,7 +2191,7 @@
           <p:nvPr/>
         </p:nvPicPr>
         <p:blipFill>
-          <a:blip xmlns:r="http://schemas.openxmlformats.org/officeDocument/2006/relationships" xmlns:a="http://schemas.openxmlformats.org/drawingml/2006/main" r:embed="Rb1f3a3b374ec4b2c"/>
+          <a:blip xmlns:r="http://schemas.openxmlformats.org/officeDocument/2006/relationships" xmlns:a="http://schemas.openxmlformats.org/drawingml/2006/main" r:embed="R1d285d8eee054fc6"/>
           <a:srcRect xmlns:a="http://schemas.openxmlformats.org/drawingml/2006/main" l="0" t="0" r="0" b="0"/>
           <a:stretch xmlns:a="http://schemas.openxmlformats.org/drawingml/2006/main">
             <a:fillRect l="0" t="0" r="0" b="0"/>
@@ -2344,14 +2210,14 @@
     </p:spTree>
     <p:extLst>
       <p:ext uri="{BB962C8B-B14F-4D97-AF65-F5344CB8AC3E}">
-        <p14:creationId xmlns:p14="http://schemas.microsoft.com/office/powerpoint/2010/main" val="1774910196"/>
+        <p14:creationId xmlns:p14="http://schemas.microsoft.com/office/powerpoint/2010/main" val="580618583"/>
       </p:ext>
     </p:extLst>
   </p:cSld>
 </p:sld>
 </file>
 
-<file path=ppt/slides/slide7.xml><?xml version="1.0" encoding="utf-8"?>
+<file path=ppt/slides/slide9.xml><?xml version="1.0" encoding="utf-8"?>
 <p:sld xmlns:p="http://schemas.openxmlformats.org/presentationml/2006/main">
   <p:cSld>
     <p:bg>
@@ -2379,7 +2245,7 @@
           <p:nvPr/>
         </p:nvPicPr>
         <p:blipFill>
-          <a:blip xmlns:r="http://schemas.openxmlformats.org/officeDocument/2006/relationships" xmlns:a="http://schemas.openxmlformats.org/drawingml/2006/main" r:embed="R3098ec886d744d78"/>
+          <a:blip xmlns:r="http://schemas.openxmlformats.org/officeDocument/2006/relationships" xmlns:a="http://schemas.openxmlformats.org/drawingml/2006/main" r:embed="R56a7082471ae4dae"/>
           <a:srcRect xmlns:a="http://schemas.openxmlformats.org/drawingml/2006/main" l="0" t="0" r="0" b="0"/>
           <a:stretch xmlns:a="http://schemas.openxmlformats.org/drawingml/2006/main">
             <a:fillRect l="0" t="0" r="0" b="0"/>
@@ -2398,115 +2264,7 @@
     </p:spTree>
     <p:extLst>
       <p:ext uri="{BB962C8B-B14F-4D97-AF65-F5344CB8AC3E}">
-        <p14:creationId xmlns:p14="http://schemas.microsoft.com/office/powerpoint/2010/main" val="1557831620"/>
-      </p:ext>
-    </p:extLst>
-  </p:cSld>
-</p:sld>
-</file>
-
-<file path=ppt/slides/slide8.xml><?xml version="1.0" encoding="utf-8"?>
-<p:sld xmlns:p="http://schemas.openxmlformats.org/presentationml/2006/main">
-  <p:cSld>
-    <p:bg>
-      <p:bgPr>
-        <a:solidFill xmlns:a="http://schemas.openxmlformats.org/drawingml/2006/main">
-          <a:srgbClr val="FAFAF8"/>
-        </a:solidFill>
-      </p:bgPr>
-    </p:bg>
-    <p:spTree>
-      <p:nvGrpSpPr>
-        <p:cNvPr id="1" name=""/>
-        <p:cNvGrpSpPr/>
-        <p:nvPr/>
-      </p:nvGrpSpPr>
-      <p:grpSpPr>
-        <a:xfrm xmlns:a="http://schemas.openxmlformats.org/drawingml/2006/main"/>
-      </p:grpSpPr>
-      <p:pic>
-        <p:nvPicPr>
-          <p:cNvPr id="2" name=""/>
-          <p:cNvPicPr>
-            <a:picLocks xmlns:a="http://schemas.openxmlformats.org/drawingml/2006/main" noChangeAspect="1"/>
-          </p:cNvPicPr>
-          <p:nvPr/>
-        </p:nvPicPr>
-        <p:blipFill>
-          <a:blip xmlns:r="http://schemas.openxmlformats.org/officeDocument/2006/relationships" xmlns:a="http://schemas.openxmlformats.org/drawingml/2006/main" r:embed="Rdae2b159fd9340dd"/>
-          <a:srcRect xmlns:a="http://schemas.openxmlformats.org/drawingml/2006/main" l="0" t="0" r="0" b="0"/>
-          <a:stretch xmlns:a="http://schemas.openxmlformats.org/drawingml/2006/main">
-            <a:fillRect l="0" t="0" r="0" b="0"/>
-          </a:stretch>
-        </p:blipFill>
-        <p:spPr>
-          <a:xfrm xmlns:a="http://schemas.openxmlformats.org/drawingml/2006/main">
-            <a:off x="0" y="0"/>
-            <a:ext cx="12192000" cy="6858000"/>
-          </a:xfrm>
-          <a:prstGeom xmlns:a="http://schemas.openxmlformats.org/drawingml/2006/main" prst="rect">
-            <a:avLst/>
-          </a:prstGeom>
-        </p:spPr>
-      </p:pic>
-    </p:spTree>
-    <p:extLst>
-      <p:ext uri="{BB962C8B-B14F-4D97-AF65-F5344CB8AC3E}">
-        <p14:creationId xmlns:p14="http://schemas.microsoft.com/office/powerpoint/2010/main" val="620352547"/>
-      </p:ext>
-    </p:extLst>
-  </p:cSld>
-</p:sld>
-</file>
-
-<file path=ppt/slides/slide9.xml><?xml version="1.0" encoding="utf-8"?>
-<p:sld xmlns:p="http://schemas.openxmlformats.org/presentationml/2006/main">
-  <p:cSld>
-    <p:bg>
-      <p:bgPr>
-        <a:solidFill xmlns:a="http://schemas.openxmlformats.org/drawingml/2006/main">
-          <a:srgbClr val="FAFAF8"/>
-        </a:solidFill>
-      </p:bgPr>
-    </p:bg>
-    <p:spTree>
-      <p:nvGrpSpPr>
-        <p:cNvPr id="1" name=""/>
-        <p:cNvGrpSpPr/>
-        <p:nvPr/>
-      </p:nvGrpSpPr>
-      <p:grpSpPr>
-        <a:xfrm xmlns:a="http://schemas.openxmlformats.org/drawingml/2006/main"/>
-      </p:grpSpPr>
-      <p:pic>
-        <p:nvPicPr>
-          <p:cNvPr id="2" name=""/>
-          <p:cNvPicPr>
-            <a:picLocks xmlns:a="http://schemas.openxmlformats.org/drawingml/2006/main" noChangeAspect="1"/>
-          </p:cNvPicPr>
-          <p:nvPr/>
-        </p:nvPicPr>
-        <p:blipFill>
-          <a:blip xmlns:r="http://schemas.openxmlformats.org/officeDocument/2006/relationships" xmlns:a="http://schemas.openxmlformats.org/drawingml/2006/main" r:embed="R30d8ba2f1d72459b"/>
-          <a:srcRect xmlns:a="http://schemas.openxmlformats.org/drawingml/2006/main" l="0" t="0" r="0" b="0"/>
-          <a:stretch xmlns:a="http://schemas.openxmlformats.org/drawingml/2006/main">
-            <a:fillRect l="0" t="0" r="0" b="0"/>
-          </a:stretch>
-        </p:blipFill>
-        <p:spPr>
-          <a:xfrm xmlns:a="http://schemas.openxmlformats.org/drawingml/2006/main">
-            <a:off x="0" y="0"/>
-            <a:ext cx="12192000" cy="6858000"/>
-          </a:xfrm>
-          <a:prstGeom xmlns:a="http://schemas.openxmlformats.org/drawingml/2006/main" prst="rect">
-            <a:avLst/>
-          </a:prstGeom>
-        </p:spPr>
-      </p:pic>
-    </p:spTree>
-    <p:extLst>
-      <p:ext uri="{BB962C8B-B14F-4D97-AF65-F5344CB8AC3E}">
-        <p14:creationId xmlns:p14="http://schemas.microsoft.com/office/powerpoint/2010/main" val="1574891851"/>
+        <p14:creationId xmlns:p14="http://schemas.microsoft.com/office/powerpoint/2010/main" val="1881459742"/>
       </p:ext>
     </p:extLst>
   </p:cSld>

</xml_diff>